<commit_message>
Add per-level OLS regression lines to Section 10 CG-vs-CKD-EPI scatters
plot_cg_vs_epi (used by panels 10.1-10.5) now overlays two OLS
regression lines -- one per level of the highlighted binary
(TRUE/FALSE for the age/BMI threshold). Line colour and the light
15%-alpha CI ribbon match the dot colour: red for the "highlighted"
level, grey60 for the reference level. The dashed y = x line and
the 0-200 axis frame are unchanged.

The 10.6 sex panel gets the same treatment: one OLS line per sex
(Female red, Male grey) with a matching CI ribbon. Fill scale is
added with guide = "none" so the colour legend still only reports
the two sexes.

Uses geom_smooth(method = "lm", formula = y ~ x); grouping is
implicit from the color aesthetic in the ggplot() call, so no
manual per-level fitting is needed.

Co-Authored-By: Claude Opus 4.6 (1M context) <noreply@anthropic.com>
</commit_message>
<xml_diff>
--- a/docs/pptx/whole/jx-scatter-cg-epi-age70.pptx
+++ b/docs/pptx/whole/jx-scatter-cg-epi-age70.pptx
@@ -36084,7 +36084,2052 @@
         </p:sp>
         <p:sp>
           <p:nvSpPr>
-            <p:cNvPr id="966" name="tx966"/>
+            <p:cNvPr id="966" name="pg966"/>
+            <p:cNvSpPr/>
+            <p:nvPr/>
+          </p:nvSpPr>
+          <p:spPr>
+            <a:xfrm>
+              <a:off x="2349376" y="2900874"/>
+              <a:ext cx="6267834" cy="1664287"/>
+            </a:xfrm>
+            <a:custGeom>
+              <a:avLst/>
+              <a:pathLst>
+                <a:path w="6267834" h="1664287">
+                  <a:moveTo>
+                    <a:pt x="0" y="1565883"/>
+                  </a:moveTo>
+                  <a:lnTo>
+                    <a:pt x="158321" y="1529316"/>
+                  </a:lnTo>
+                  <a:lnTo>
+                    <a:pt x="316643" y="1492712"/>
+                  </a:lnTo>
+                  <a:lnTo>
+                    <a:pt x="474965" y="1456067"/>
+                  </a:lnTo>
+                  <a:lnTo>
+                    <a:pt x="633286" y="1419373"/>
+                  </a:lnTo>
+                  <a:lnTo>
+                    <a:pt x="791608" y="1382619"/>
+                  </a:lnTo>
+                  <a:lnTo>
+                    <a:pt x="949930" y="1345796"/>
+                  </a:lnTo>
+                  <a:lnTo>
+                    <a:pt x="1108251" y="1308888"/>
+                  </a:lnTo>
+                  <a:lnTo>
+                    <a:pt x="1266573" y="1271877"/>
+                  </a:lnTo>
+                  <a:lnTo>
+                    <a:pt x="1424895" y="1234743"/>
+                  </a:lnTo>
+                  <a:lnTo>
+                    <a:pt x="1583217" y="1197459"/>
+                  </a:lnTo>
+                  <a:lnTo>
+                    <a:pt x="1741538" y="1159994"/>
+                  </a:lnTo>
+                  <a:lnTo>
+                    <a:pt x="1899860" y="1122312"/>
+                  </a:lnTo>
+                  <a:lnTo>
+                    <a:pt x="2058182" y="1084376"/>
+                  </a:lnTo>
+                  <a:lnTo>
+                    <a:pt x="2216503" y="1046147"/>
+                  </a:lnTo>
+                  <a:lnTo>
+                    <a:pt x="2374825" y="1007592"/>
+                  </a:lnTo>
+                  <a:lnTo>
+                    <a:pt x="2533147" y="968688"/>
+                  </a:lnTo>
+                  <a:lnTo>
+                    <a:pt x="2691468" y="929431"/>
+                  </a:lnTo>
+                  <a:lnTo>
+                    <a:pt x="2849790" y="889828"/>
+                  </a:lnTo>
+                  <a:lnTo>
+                    <a:pt x="3008112" y="849905"/>
+                  </a:lnTo>
+                  <a:lnTo>
+                    <a:pt x="3166434" y="809696"/>
+                  </a:lnTo>
+                  <a:lnTo>
+                    <a:pt x="3324755" y="769241"/>
+                  </a:lnTo>
+                  <a:lnTo>
+                    <a:pt x="3483077" y="728576"/>
+                  </a:lnTo>
+                  <a:lnTo>
+                    <a:pt x="3641399" y="687736"/>
+                  </a:lnTo>
+                  <a:lnTo>
+                    <a:pt x="3799720" y="646752"/>
+                  </a:lnTo>
+                  <a:lnTo>
+                    <a:pt x="3958042" y="605648"/>
+                  </a:lnTo>
+                  <a:lnTo>
+                    <a:pt x="4116364" y="564446"/>
+                  </a:lnTo>
+                  <a:lnTo>
+                    <a:pt x="4274685" y="523163"/>
+                  </a:lnTo>
+                  <a:lnTo>
+                    <a:pt x="4433007" y="481811"/>
+                  </a:lnTo>
+                  <a:lnTo>
+                    <a:pt x="4591329" y="440403"/>
+                  </a:lnTo>
+                  <a:lnTo>
+                    <a:pt x="4749651" y="398947"/>
+                  </a:lnTo>
+                  <a:lnTo>
+                    <a:pt x="4907972" y="357451"/>
+                  </a:lnTo>
+                  <a:lnTo>
+                    <a:pt x="5066294" y="315920"/>
+                  </a:lnTo>
+                  <a:lnTo>
+                    <a:pt x="5224616" y="274359"/>
+                  </a:lnTo>
+                  <a:lnTo>
+                    <a:pt x="5382937" y="232773"/>
+                  </a:lnTo>
+                  <a:lnTo>
+                    <a:pt x="5541259" y="191165"/>
+                  </a:lnTo>
+                  <a:lnTo>
+                    <a:pt x="5699581" y="149537"/>
+                  </a:lnTo>
+                  <a:lnTo>
+                    <a:pt x="5857902" y="107893"/>
+                  </a:lnTo>
+                  <a:lnTo>
+                    <a:pt x="6016224" y="66233"/>
+                  </a:lnTo>
+                  <a:lnTo>
+                    <a:pt x="6174546" y="24561"/>
+                  </a:lnTo>
+                  <a:lnTo>
+                    <a:pt x="6267834" y="0"/>
+                  </a:lnTo>
+                  <a:lnTo>
+                    <a:pt x="6267834" y="138548"/>
+                  </a:lnTo>
+                  <a:lnTo>
+                    <a:pt x="6174546" y="160001"/>
+                  </a:lnTo>
+                  <a:lnTo>
+                    <a:pt x="6016224" y="196421"/>
+                  </a:lnTo>
+                  <a:lnTo>
+                    <a:pt x="5857902" y="232855"/>
+                  </a:lnTo>
+                  <a:lnTo>
+                    <a:pt x="5699581" y="269303"/>
+                  </a:lnTo>
+                  <a:lnTo>
+                    <a:pt x="5541259" y="305768"/>
+                  </a:lnTo>
+                  <a:lnTo>
+                    <a:pt x="5382937" y="342252"/>
+                  </a:lnTo>
+                  <a:lnTo>
+                    <a:pt x="5224616" y="378758"/>
+                  </a:lnTo>
+                  <a:lnTo>
+                    <a:pt x="5066294" y="415290"/>
+                  </a:lnTo>
+                  <a:lnTo>
+                    <a:pt x="4907972" y="451852"/>
+                  </a:lnTo>
+                  <a:lnTo>
+                    <a:pt x="4749651" y="488448"/>
+                  </a:lnTo>
+                  <a:lnTo>
+                    <a:pt x="4591329" y="525084"/>
+                  </a:lnTo>
+                  <a:lnTo>
+                    <a:pt x="4433007" y="561768"/>
+                  </a:lnTo>
+                  <a:lnTo>
+                    <a:pt x="4274685" y="598510"/>
+                  </a:lnTo>
+                  <a:lnTo>
+                    <a:pt x="4116364" y="635319"/>
+                  </a:lnTo>
+                  <a:lnTo>
+                    <a:pt x="3958042" y="672209"/>
+                  </a:lnTo>
+                  <a:lnTo>
+                    <a:pt x="3799720" y="709198"/>
+                  </a:lnTo>
+                  <a:lnTo>
+                    <a:pt x="3641399" y="746307"/>
+                  </a:lnTo>
+                  <a:lnTo>
+                    <a:pt x="3483077" y="783560"/>
+                  </a:lnTo>
+                  <a:lnTo>
+                    <a:pt x="3324755" y="820987"/>
+                  </a:lnTo>
+                  <a:lnTo>
+                    <a:pt x="3166434" y="858624"/>
+                  </a:lnTo>
+                  <a:lnTo>
+                    <a:pt x="3008112" y="896508"/>
+                  </a:lnTo>
+                  <a:lnTo>
+                    <a:pt x="2849790" y="934677"/>
+                  </a:lnTo>
+                  <a:lnTo>
+                    <a:pt x="2691468" y="973167"/>
+                  </a:lnTo>
+                  <a:lnTo>
+                    <a:pt x="2533147" y="1012002"/>
+                  </a:lnTo>
+                  <a:lnTo>
+                    <a:pt x="2374825" y="1051191"/>
+                  </a:lnTo>
+                  <a:lnTo>
+                    <a:pt x="2216503" y="1090729"/>
+                  </a:lnTo>
+                  <a:lnTo>
+                    <a:pt x="2058182" y="1130592"/>
+                  </a:lnTo>
+                  <a:lnTo>
+                    <a:pt x="1899860" y="1170748"/>
+                  </a:lnTo>
+                  <a:lnTo>
+                    <a:pt x="1741538" y="1211159"/>
+                  </a:lnTo>
+                  <a:lnTo>
+                    <a:pt x="1583217" y="1251787"/>
+                  </a:lnTo>
+                  <a:lnTo>
+                    <a:pt x="1424895" y="1292595"/>
+                  </a:lnTo>
+                  <a:lnTo>
+                    <a:pt x="1266573" y="1333553"/>
+                  </a:lnTo>
+                  <a:lnTo>
+                    <a:pt x="1108251" y="1374636"/>
+                  </a:lnTo>
+                  <a:lnTo>
+                    <a:pt x="949930" y="1415820"/>
+                  </a:lnTo>
+                  <a:lnTo>
+                    <a:pt x="791608" y="1457089"/>
+                  </a:lnTo>
+                  <a:lnTo>
+                    <a:pt x="633286" y="1498428"/>
+                  </a:lnTo>
+                  <a:lnTo>
+                    <a:pt x="474965" y="1539826"/>
+                  </a:lnTo>
+                  <a:lnTo>
+                    <a:pt x="316643" y="1581273"/>
+                  </a:lnTo>
+                  <a:lnTo>
+                    <a:pt x="158321" y="1622763"/>
+                  </a:lnTo>
+                  <a:lnTo>
+                    <a:pt x="0" y="1664287"/>
+                  </a:lnTo>
+                  <a:close/>
+                </a:path>
+              </a:pathLst>
+            </a:custGeom>
+            <a:solidFill>
+              <a:srgbClr val="999999">
+                <a:alpha val="14901"/>
+              </a:srgbClr>
+            </a:solidFill>
+          </p:spPr>
+          <p:txBody>
+            <a:bodyPr/>
+            <a:lstStyle/>
+            <a:p/>
+          </p:txBody>
+        </p:sp>
+        <p:sp>
+          <p:nvSpPr>
+            <p:cNvPr id="967" name="pl967"/>
+            <p:cNvSpPr/>
+            <p:nvPr/>
+          </p:nvSpPr>
+          <p:spPr>
+            <a:xfrm>
+              <a:off x="2349376" y="2900874"/>
+              <a:ext cx="6267834" cy="1565883"/>
+            </a:xfrm>
+            <a:custGeom>
+              <a:avLst/>
+              <a:pathLst>
+                <a:path w="6267834" h="1565883">
+                  <a:moveTo>
+                    <a:pt x="0" y="1565883"/>
+                  </a:moveTo>
+                  <a:lnTo>
+                    <a:pt x="158321" y="1529316"/>
+                  </a:lnTo>
+                  <a:lnTo>
+                    <a:pt x="316643" y="1492712"/>
+                  </a:lnTo>
+                  <a:lnTo>
+                    <a:pt x="474965" y="1456067"/>
+                  </a:lnTo>
+                  <a:lnTo>
+                    <a:pt x="633286" y="1419373"/>
+                  </a:lnTo>
+                  <a:lnTo>
+                    <a:pt x="791608" y="1382619"/>
+                  </a:lnTo>
+                  <a:lnTo>
+                    <a:pt x="949930" y="1345796"/>
+                  </a:lnTo>
+                  <a:lnTo>
+                    <a:pt x="1108251" y="1308888"/>
+                  </a:lnTo>
+                  <a:lnTo>
+                    <a:pt x="1266573" y="1271877"/>
+                  </a:lnTo>
+                  <a:lnTo>
+                    <a:pt x="1424895" y="1234743"/>
+                  </a:lnTo>
+                  <a:lnTo>
+                    <a:pt x="1583217" y="1197459"/>
+                  </a:lnTo>
+                  <a:lnTo>
+                    <a:pt x="1741538" y="1159994"/>
+                  </a:lnTo>
+                  <a:lnTo>
+                    <a:pt x="1899860" y="1122312"/>
+                  </a:lnTo>
+                  <a:lnTo>
+                    <a:pt x="2058182" y="1084376"/>
+                  </a:lnTo>
+                  <a:lnTo>
+                    <a:pt x="2216503" y="1046147"/>
+                  </a:lnTo>
+                  <a:lnTo>
+                    <a:pt x="2374825" y="1007592"/>
+                  </a:lnTo>
+                  <a:lnTo>
+                    <a:pt x="2533147" y="968688"/>
+                  </a:lnTo>
+                  <a:lnTo>
+                    <a:pt x="2691468" y="929431"/>
+                  </a:lnTo>
+                  <a:lnTo>
+                    <a:pt x="2849790" y="889828"/>
+                  </a:lnTo>
+                  <a:lnTo>
+                    <a:pt x="3008112" y="849905"/>
+                  </a:lnTo>
+                  <a:lnTo>
+                    <a:pt x="3166434" y="809696"/>
+                  </a:lnTo>
+                  <a:lnTo>
+                    <a:pt x="3324755" y="769241"/>
+                  </a:lnTo>
+                  <a:lnTo>
+                    <a:pt x="3483077" y="728576"/>
+                  </a:lnTo>
+                  <a:lnTo>
+                    <a:pt x="3641399" y="687736"/>
+                  </a:lnTo>
+                  <a:lnTo>
+                    <a:pt x="3799720" y="646752"/>
+                  </a:lnTo>
+                  <a:lnTo>
+                    <a:pt x="3958042" y="605648"/>
+                  </a:lnTo>
+                  <a:lnTo>
+                    <a:pt x="4116364" y="564446"/>
+                  </a:lnTo>
+                  <a:lnTo>
+                    <a:pt x="4274685" y="523163"/>
+                  </a:lnTo>
+                  <a:lnTo>
+                    <a:pt x="4433007" y="481811"/>
+                  </a:lnTo>
+                  <a:lnTo>
+                    <a:pt x="4591329" y="440403"/>
+                  </a:lnTo>
+                  <a:lnTo>
+                    <a:pt x="4749651" y="398947"/>
+                  </a:lnTo>
+                  <a:lnTo>
+                    <a:pt x="4907972" y="357451"/>
+                  </a:lnTo>
+                  <a:lnTo>
+                    <a:pt x="5066294" y="315920"/>
+                  </a:lnTo>
+                  <a:lnTo>
+                    <a:pt x="5224616" y="274359"/>
+                  </a:lnTo>
+                  <a:lnTo>
+                    <a:pt x="5382937" y="232773"/>
+                  </a:lnTo>
+                  <a:lnTo>
+                    <a:pt x="5541259" y="191165"/>
+                  </a:lnTo>
+                  <a:lnTo>
+                    <a:pt x="5699581" y="149537"/>
+                  </a:lnTo>
+                  <a:lnTo>
+                    <a:pt x="5857902" y="107893"/>
+                  </a:lnTo>
+                  <a:lnTo>
+                    <a:pt x="6016224" y="66233"/>
+                  </a:lnTo>
+                  <a:lnTo>
+                    <a:pt x="6174546" y="24561"/>
+                  </a:lnTo>
+                  <a:lnTo>
+                    <a:pt x="6267834" y="0"/>
+                  </a:lnTo>
+                </a:path>
+              </a:pathLst>
+            </a:custGeom>
+          </p:spPr>
+          <p:txBody>
+            <a:bodyPr/>
+            <a:lstStyle/>
+            <a:p/>
+          </p:txBody>
+        </p:sp>
+        <p:sp>
+          <p:nvSpPr>
+            <p:cNvPr id="968" name="pl968"/>
+            <p:cNvSpPr/>
+            <p:nvPr/>
+          </p:nvSpPr>
+          <p:spPr>
+            <a:xfrm>
+              <a:off x="2349376" y="3039423"/>
+              <a:ext cx="6267834" cy="1525739"/>
+            </a:xfrm>
+            <a:custGeom>
+              <a:avLst/>
+              <a:pathLst>
+                <a:path w="6267834" h="1525739">
+                  <a:moveTo>
+                    <a:pt x="6267834" y="0"/>
+                  </a:moveTo>
+                  <a:lnTo>
+                    <a:pt x="6174546" y="21452"/>
+                  </a:lnTo>
+                  <a:lnTo>
+                    <a:pt x="6016224" y="57873"/>
+                  </a:lnTo>
+                  <a:lnTo>
+                    <a:pt x="5857902" y="94306"/>
+                  </a:lnTo>
+                  <a:lnTo>
+                    <a:pt x="5699581" y="130754"/>
+                  </a:lnTo>
+                  <a:lnTo>
+                    <a:pt x="5541259" y="167219"/>
+                  </a:lnTo>
+                  <a:lnTo>
+                    <a:pt x="5382937" y="203703"/>
+                  </a:lnTo>
+                  <a:lnTo>
+                    <a:pt x="5224616" y="240210"/>
+                  </a:lnTo>
+                  <a:lnTo>
+                    <a:pt x="5066294" y="276741"/>
+                  </a:lnTo>
+                  <a:lnTo>
+                    <a:pt x="4907972" y="313303"/>
+                  </a:lnTo>
+                  <a:lnTo>
+                    <a:pt x="4749651" y="349899"/>
+                  </a:lnTo>
+                  <a:lnTo>
+                    <a:pt x="4591329" y="386535"/>
+                  </a:lnTo>
+                  <a:lnTo>
+                    <a:pt x="4433007" y="423220"/>
+                  </a:lnTo>
+                  <a:lnTo>
+                    <a:pt x="4274685" y="459961"/>
+                  </a:lnTo>
+                  <a:lnTo>
+                    <a:pt x="4116364" y="496770"/>
+                  </a:lnTo>
+                  <a:lnTo>
+                    <a:pt x="3958042" y="533660"/>
+                  </a:lnTo>
+                  <a:lnTo>
+                    <a:pt x="3799720" y="570650"/>
+                  </a:lnTo>
+                  <a:lnTo>
+                    <a:pt x="3641399" y="607758"/>
+                  </a:lnTo>
+                  <a:lnTo>
+                    <a:pt x="3483077" y="645011"/>
+                  </a:lnTo>
+                  <a:lnTo>
+                    <a:pt x="3324755" y="682438"/>
+                  </a:lnTo>
+                  <a:lnTo>
+                    <a:pt x="3166434" y="720075"/>
+                  </a:lnTo>
+                  <a:lnTo>
+                    <a:pt x="3008112" y="757959"/>
+                  </a:lnTo>
+                  <a:lnTo>
+                    <a:pt x="2849790" y="796129"/>
+                  </a:lnTo>
+                  <a:lnTo>
+                    <a:pt x="2691468" y="834618"/>
+                  </a:lnTo>
+                  <a:lnTo>
+                    <a:pt x="2533147" y="873453"/>
+                  </a:lnTo>
+                  <a:lnTo>
+                    <a:pt x="2374825" y="912643"/>
+                  </a:lnTo>
+                  <a:lnTo>
+                    <a:pt x="2216503" y="952180"/>
+                  </a:lnTo>
+                  <a:lnTo>
+                    <a:pt x="2058182" y="992043"/>
+                  </a:lnTo>
+                  <a:lnTo>
+                    <a:pt x="1899860" y="1032200"/>
+                  </a:lnTo>
+                  <a:lnTo>
+                    <a:pt x="1741538" y="1072611"/>
+                  </a:lnTo>
+                  <a:lnTo>
+                    <a:pt x="1583217" y="1113238"/>
+                  </a:lnTo>
+                  <a:lnTo>
+                    <a:pt x="1424895" y="1154046"/>
+                  </a:lnTo>
+                  <a:lnTo>
+                    <a:pt x="1266573" y="1195005"/>
+                  </a:lnTo>
+                  <a:lnTo>
+                    <a:pt x="1108251" y="1236087"/>
+                  </a:lnTo>
+                  <a:lnTo>
+                    <a:pt x="949930" y="1277271"/>
+                  </a:lnTo>
+                  <a:lnTo>
+                    <a:pt x="791608" y="1318540"/>
+                  </a:lnTo>
+                  <a:lnTo>
+                    <a:pt x="633286" y="1359879"/>
+                  </a:lnTo>
+                  <a:lnTo>
+                    <a:pt x="474965" y="1401277"/>
+                  </a:lnTo>
+                  <a:lnTo>
+                    <a:pt x="316643" y="1442725"/>
+                  </a:lnTo>
+                  <a:lnTo>
+                    <a:pt x="158321" y="1484214"/>
+                  </a:lnTo>
+                  <a:lnTo>
+                    <a:pt x="0" y="1525739"/>
+                  </a:lnTo>
+                </a:path>
+              </a:pathLst>
+            </a:custGeom>
+          </p:spPr>
+          <p:txBody>
+            <a:bodyPr/>
+            <a:lstStyle/>
+            <a:p/>
+          </p:txBody>
+        </p:sp>
+        <p:sp>
+          <p:nvSpPr>
+            <p:cNvPr id="969" name="pl969"/>
+            <p:cNvSpPr/>
+            <p:nvPr/>
+          </p:nvSpPr>
+          <p:spPr>
+            <a:xfrm>
+              <a:off x="2349376" y="2970149"/>
+              <a:ext cx="6267834" cy="1545811"/>
+            </a:xfrm>
+            <a:custGeom>
+              <a:avLst/>
+              <a:pathLst>
+                <a:path w="6267834" h="1545811">
+                  <a:moveTo>
+                    <a:pt x="0" y="1545811"/>
+                  </a:moveTo>
+                  <a:lnTo>
+                    <a:pt x="158321" y="1506765"/>
+                  </a:lnTo>
+                  <a:lnTo>
+                    <a:pt x="316643" y="1467718"/>
+                  </a:lnTo>
+                  <a:lnTo>
+                    <a:pt x="474965" y="1428672"/>
+                  </a:lnTo>
+                  <a:lnTo>
+                    <a:pt x="633286" y="1389626"/>
+                  </a:lnTo>
+                  <a:lnTo>
+                    <a:pt x="791608" y="1350580"/>
+                  </a:lnTo>
+                  <a:lnTo>
+                    <a:pt x="949930" y="1311533"/>
+                  </a:lnTo>
+                  <a:lnTo>
+                    <a:pt x="1108251" y="1272487"/>
+                  </a:lnTo>
+                  <a:lnTo>
+                    <a:pt x="1266573" y="1233441"/>
+                  </a:lnTo>
+                  <a:lnTo>
+                    <a:pt x="1424895" y="1194395"/>
+                  </a:lnTo>
+                  <a:lnTo>
+                    <a:pt x="1583217" y="1155348"/>
+                  </a:lnTo>
+                  <a:lnTo>
+                    <a:pt x="1741538" y="1116302"/>
+                  </a:lnTo>
+                  <a:lnTo>
+                    <a:pt x="1899860" y="1077256"/>
+                  </a:lnTo>
+                  <a:lnTo>
+                    <a:pt x="2058182" y="1038210"/>
+                  </a:lnTo>
+                  <a:lnTo>
+                    <a:pt x="2216503" y="999163"/>
+                  </a:lnTo>
+                  <a:lnTo>
+                    <a:pt x="2374825" y="960117"/>
+                  </a:lnTo>
+                  <a:lnTo>
+                    <a:pt x="2533147" y="921071"/>
+                  </a:lnTo>
+                  <a:lnTo>
+                    <a:pt x="2691468" y="882024"/>
+                  </a:lnTo>
+                  <a:lnTo>
+                    <a:pt x="2849790" y="842978"/>
+                  </a:lnTo>
+                  <a:lnTo>
+                    <a:pt x="3008112" y="803932"/>
+                  </a:lnTo>
+                  <a:lnTo>
+                    <a:pt x="3166434" y="764886"/>
+                  </a:lnTo>
+                  <a:lnTo>
+                    <a:pt x="3324755" y="725839"/>
+                  </a:lnTo>
+                  <a:lnTo>
+                    <a:pt x="3483077" y="686793"/>
+                  </a:lnTo>
+                  <a:lnTo>
+                    <a:pt x="3641399" y="647747"/>
+                  </a:lnTo>
+                  <a:lnTo>
+                    <a:pt x="3799720" y="608701"/>
+                  </a:lnTo>
+                  <a:lnTo>
+                    <a:pt x="3958042" y="569654"/>
+                  </a:lnTo>
+                  <a:lnTo>
+                    <a:pt x="4116364" y="530608"/>
+                  </a:lnTo>
+                  <a:lnTo>
+                    <a:pt x="4274685" y="491562"/>
+                  </a:lnTo>
+                  <a:lnTo>
+                    <a:pt x="4433007" y="452516"/>
+                  </a:lnTo>
+                  <a:lnTo>
+                    <a:pt x="4591329" y="413469"/>
+                  </a:lnTo>
+                  <a:lnTo>
+                    <a:pt x="4749651" y="374423"/>
+                  </a:lnTo>
+                  <a:lnTo>
+                    <a:pt x="4907972" y="335377"/>
+                  </a:lnTo>
+                  <a:lnTo>
+                    <a:pt x="5066294" y="296331"/>
+                  </a:lnTo>
+                  <a:lnTo>
+                    <a:pt x="5224616" y="257284"/>
+                  </a:lnTo>
+                  <a:lnTo>
+                    <a:pt x="5382937" y="218238"/>
+                  </a:lnTo>
+                  <a:lnTo>
+                    <a:pt x="5541259" y="179192"/>
+                  </a:lnTo>
+                  <a:lnTo>
+                    <a:pt x="5699581" y="140145"/>
+                  </a:lnTo>
+                  <a:lnTo>
+                    <a:pt x="5857902" y="101099"/>
+                  </a:lnTo>
+                  <a:lnTo>
+                    <a:pt x="6016224" y="62053"/>
+                  </a:lnTo>
+                  <a:lnTo>
+                    <a:pt x="6174546" y="23007"/>
+                  </a:lnTo>
+                  <a:lnTo>
+                    <a:pt x="6267834" y="0"/>
+                  </a:lnTo>
+                </a:path>
+              </a:pathLst>
+            </a:custGeom>
+            <a:ln w="27101" cap="flat">
+              <a:solidFill>
+                <a:srgbClr val="999999">
+                  <a:alpha val="100000"/>
+                </a:srgbClr>
+              </a:solidFill>
+              <a:prstDash val="solid"/>
+              <a:round/>
+            </a:ln>
+          </p:spPr>
+          <p:txBody>
+            <a:bodyPr/>
+            <a:lstStyle/>
+            <a:p/>
+          </p:txBody>
+        </p:sp>
+        <p:sp>
+          <p:nvSpPr>
+            <p:cNvPr id="970" name="pg970"/>
+            <p:cNvSpPr/>
+            <p:nvPr/>
+          </p:nvSpPr>
+          <p:spPr>
+            <a:xfrm>
+              <a:off x="1985667" y="2603546"/>
+              <a:ext cx="5970104" cy="2372748"/>
+            </a:xfrm>
+            <a:custGeom>
+              <a:avLst/>
+              <a:pathLst>
+                <a:path w="5970104" h="2372748">
+                  <a:moveTo>
+                    <a:pt x="0" y="2256621"/>
+                  </a:moveTo>
+                  <a:lnTo>
+                    <a:pt x="75570" y="2231139"/>
+                  </a:lnTo>
+                  <a:lnTo>
+                    <a:pt x="151141" y="2205639"/>
+                  </a:lnTo>
+                  <a:lnTo>
+                    <a:pt x="226712" y="2180119"/>
+                  </a:lnTo>
+                  <a:lnTo>
+                    <a:pt x="302283" y="2154576"/>
+                  </a:lnTo>
+                  <a:lnTo>
+                    <a:pt x="377854" y="2129008"/>
+                  </a:lnTo>
+                  <a:lnTo>
+                    <a:pt x="453425" y="2103411"/>
+                  </a:lnTo>
+                  <a:lnTo>
+                    <a:pt x="528996" y="2077781"/>
+                  </a:lnTo>
+                  <a:lnTo>
+                    <a:pt x="604567" y="2052113"/>
+                  </a:lnTo>
+                  <a:lnTo>
+                    <a:pt x="680138" y="2026401"/>
+                  </a:lnTo>
+                  <a:lnTo>
+                    <a:pt x="755709" y="2000641"/>
+                  </a:lnTo>
+                  <a:lnTo>
+                    <a:pt x="831280" y="1974823"/>
+                  </a:lnTo>
+                  <a:lnTo>
+                    <a:pt x="906851" y="1948938"/>
+                  </a:lnTo>
+                  <a:lnTo>
+                    <a:pt x="982422" y="1922978"/>
+                  </a:lnTo>
+                  <a:lnTo>
+                    <a:pt x="1057993" y="1896929"/>
+                  </a:lnTo>
+                  <a:lnTo>
+                    <a:pt x="1133564" y="1870777"/>
+                  </a:lnTo>
+                  <a:lnTo>
+                    <a:pt x="1209135" y="1844507"/>
+                  </a:lnTo>
+                  <a:lnTo>
+                    <a:pt x="1284706" y="1818103"/>
+                  </a:lnTo>
+                  <a:lnTo>
+                    <a:pt x="1360277" y="1791544"/>
+                  </a:lnTo>
+                  <a:lnTo>
+                    <a:pt x="1435847" y="1764812"/>
+                  </a:lnTo>
+                  <a:lnTo>
+                    <a:pt x="1511418" y="1737890"/>
+                  </a:lnTo>
+                  <a:lnTo>
+                    <a:pt x="1586989" y="1710760"/>
+                  </a:lnTo>
+                  <a:lnTo>
+                    <a:pt x="1662560" y="1683410"/>
+                  </a:lnTo>
+                  <a:lnTo>
+                    <a:pt x="1738131" y="1655834"/>
+                  </a:lnTo>
+                  <a:lnTo>
+                    <a:pt x="1813702" y="1628031"/>
+                  </a:lnTo>
+                  <a:lnTo>
+                    <a:pt x="1889273" y="1600005"/>
+                  </a:lnTo>
+                  <a:lnTo>
+                    <a:pt x="1964844" y="1571770"/>
+                  </a:lnTo>
+                  <a:lnTo>
+                    <a:pt x="2040415" y="1543338"/>
+                  </a:lnTo>
+                  <a:lnTo>
+                    <a:pt x="2115986" y="1514730"/>
+                  </a:lnTo>
+                  <a:lnTo>
+                    <a:pt x="2191557" y="1485963"/>
+                  </a:lnTo>
+                  <a:lnTo>
+                    <a:pt x="2267128" y="1457056"/>
+                  </a:lnTo>
+                  <a:lnTo>
+                    <a:pt x="2342699" y="1428027"/>
+                  </a:lnTo>
+                  <a:lnTo>
+                    <a:pt x="2418270" y="1398892"/>
+                  </a:lnTo>
+                  <a:lnTo>
+                    <a:pt x="2493841" y="1369666"/>
+                  </a:lnTo>
+                  <a:lnTo>
+                    <a:pt x="2569412" y="1340360"/>
+                  </a:lnTo>
+                  <a:lnTo>
+                    <a:pt x="2644983" y="1310986"/>
+                  </a:lnTo>
+                  <a:lnTo>
+                    <a:pt x="2720554" y="1281552"/>
+                  </a:lnTo>
+                  <a:lnTo>
+                    <a:pt x="2796124" y="1252067"/>
+                  </a:lnTo>
+                  <a:lnTo>
+                    <a:pt x="2871695" y="1222537"/>
+                  </a:lnTo>
+                  <a:lnTo>
+                    <a:pt x="2947266" y="1192969"/>
+                  </a:lnTo>
+                  <a:lnTo>
+                    <a:pt x="3022837" y="1163366"/>
+                  </a:lnTo>
+                  <a:lnTo>
+                    <a:pt x="3098408" y="1133734"/>
+                  </a:lnTo>
+                  <a:lnTo>
+                    <a:pt x="3173979" y="1104075"/>
+                  </a:lnTo>
+                  <a:lnTo>
+                    <a:pt x="3249550" y="1074392"/>
+                  </a:lnTo>
+                  <a:lnTo>
+                    <a:pt x="3325121" y="1044689"/>
+                  </a:lnTo>
+                  <a:lnTo>
+                    <a:pt x="3400692" y="1014968"/>
+                  </a:lnTo>
+                  <a:lnTo>
+                    <a:pt x="3476263" y="985230"/>
+                  </a:lnTo>
+                  <a:lnTo>
+                    <a:pt x="3551834" y="955477"/>
+                  </a:lnTo>
+                  <a:lnTo>
+                    <a:pt x="3627405" y="925711"/>
+                  </a:lnTo>
+                  <a:lnTo>
+                    <a:pt x="3702976" y="895933"/>
+                  </a:lnTo>
+                  <a:lnTo>
+                    <a:pt x="3778547" y="866144"/>
+                  </a:lnTo>
+                  <a:lnTo>
+                    <a:pt x="3854118" y="836346"/>
+                  </a:lnTo>
+                  <a:lnTo>
+                    <a:pt x="3929689" y="806538"/>
+                  </a:lnTo>
+                  <a:lnTo>
+                    <a:pt x="4005260" y="776723"/>
+                  </a:lnTo>
+                  <a:lnTo>
+                    <a:pt x="4080831" y="746899"/>
+                  </a:lnTo>
+                  <a:lnTo>
+                    <a:pt x="4156401" y="717069"/>
+                  </a:lnTo>
+                  <a:lnTo>
+                    <a:pt x="4231972" y="687233"/>
+                  </a:lnTo>
+                  <a:lnTo>
+                    <a:pt x="4307543" y="657391"/>
+                  </a:lnTo>
+                  <a:lnTo>
+                    <a:pt x="4383114" y="627544"/>
+                  </a:lnTo>
+                  <a:lnTo>
+                    <a:pt x="4458685" y="597692"/>
+                  </a:lnTo>
+                  <a:lnTo>
+                    <a:pt x="4534256" y="567835"/>
+                  </a:lnTo>
+                  <a:lnTo>
+                    <a:pt x="4609827" y="537974"/>
+                  </a:lnTo>
+                  <a:lnTo>
+                    <a:pt x="4685398" y="508109"/>
+                  </a:lnTo>
+                  <a:lnTo>
+                    <a:pt x="4760969" y="478240"/>
+                  </a:lnTo>
+                  <a:lnTo>
+                    <a:pt x="4836540" y="448368"/>
+                  </a:lnTo>
+                  <a:lnTo>
+                    <a:pt x="4912111" y="418493"/>
+                  </a:lnTo>
+                  <a:lnTo>
+                    <a:pt x="4987682" y="388615"/>
+                  </a:lnTo>
+                  <a:lnTo>
+                    <a:pt x="5063253" y="358734"/>
+                  </a:lnTo>
+                  <a:lnTo>
+                    <a:pt x="5138824" y="328851"/>
+                  </a:lnTo>
+                  <a:lnTo>
+                    <a:pt x="5214395" y="298965"/>
+                  </a:lnTo>
+                  <a:lnTo>
+                    <a:pt x="5289966" y="269077"/>
+                  </a:lnTo>
+                  <a:lnTo>
+                    <a:pt x="5365537" y="239186"/>
+                  </a:lnTo>
+                  <a:lnTo>
+                    <a:pt x="5441108" y="209294"/>
+                  </a:lnTo>
+                  <a:lnTo>
+                    <a:pt x="5516678" y="179400"/>
+                  </a:lnTo>
+                  <a:lnTo>
+                    <a:pt x="5592249" y="149504"/>
+                  </a:lnTo>
+                  <a:lnTo>
+                    <a:pt x="5667820" y="119606"/>
+                  </a:lnTo>
+                  <a:lnTo>
+                    <a:pt x="5743391" y="89707"/>
+                  </a:lnTo>
+                  <a:lnTo>
+                    <a:pt x="5818962" y="59806"/>
+                  </a:lnTo>
+                  <a:lnTo>
+                    <a:pt x="5894533" y="29903"/>
+                  </a:lnTo>
+                  <a:lnTo>
+                    <a:pt x="5970104" y="0"/>
+                  </a:lnTo>
+                  <a:lnTo>
+                    <a:pt x="5970104" y="267970"/>
+                  </a:lnTo>
+                  <a:lnTo>
+                    <a:pt x="5894533" y="293274"/>
+                  </a:lnTo>
+                  <a:lnTo>
+                    <a:pt x="5818962" y="318579"/>
+                  </a:lnTo>
+                  <a:lnTo>
+                    <a:pt x="5743391" y="343886"/>
+                  </a:lnTo>
+                  <a:lnTo>
+                    <a:pt x="5667820" y="369194"/>
+                  </a:lnTo>
+                  <a:lnTo>
+                    <a:pt x="5592249" y="394504"/>
+                  </a:lnTo>
+                  <a:lnTo>
+                    <a:pt x="5516678" y="419815"/>
+                  </a:lnTo>
+                  <a:lnTo>
+                    <a:pt x="5441108" y="445129"/>
+                  </a:lnTo>
+                  <a:lnTo>
+                    <a:pt x="5365537" y="470444"/>
+                  </a:lnTo>
+                  <a:lnTo>
+                    <a:pt x="5289966" y="495761"/>
+                  </a:lnTo>
+                  <a:lnTo>
+                    <a:pt x="5214395" y="521081"/>
+                  </a:lnTo>
+                  <a:lnTo>
+                    <a:pt x="5138824" y="546402"/>
+                  </a:lnTo>
+                  <a:lnTo>
+                    <a:pt x="5063253" y="571726"/>
+                  </a:lnTo>
+                  <a:lnTo>
+                    <a:pt x="4987682" y="597053"/>
+                  </a:lnTo>
+                  <a:lnTo>
+                    <a:pt x="4912111" y="622383"/>
+                  </a:lnTo>
+                  <a:lnTo>
+                    <a:pt x="4836540" y="647715"/>
+                  </a:lnTo>
+                  <a:lnTo>
+                    <a:pt x="4760969" y="673051"/>
+                  </a:lnTo>
+                  <a:lnTo>
+                    <a:pt x="4685398" y="698390"/>
+                  </a:lnTo>
+                  <a:lnTo>
+                    <a:pt x="4609827" y="723733"/>
+                  </a:lnTo>
+                  <a:lnTo>
+                    <a:pt x="4534256" y="749079"/>
+                  </a:lnTo>
+                  <a:lnTo>
+                    <a:pt x="4458685" y="774430"/>
+                  </a:lnTo>
+                  <a:lnTo>
+                    <a:pt x="4383114" y="799785"/>
+                  </a:lnTo>
+                  <a:lnTo>
+                    <a:pt x="4307543" y="825146"/>
+                  </a:lnTo>
+                  <a:lnTo>
+                    <a:pt x="4231972" y="850511"/>
+                  </a:lnTo>
+                  <a:lnTo>
+                    <a:pt x="4156401" y="875882"/>
+                  </a:lnTo>
+                  <a:lnTo>
+                    <a:pt x="4080831" y="901260"/>
+                  </a:lnTo>
+                  <a:lnTo>
+                    <a:pt x="4005260" y="926644"/>
+                  </a:lnTo>
+                  <a:lnTo>
+                    <a:pt x="3929689" y="952036"/>
+                  </a:lnTo>
+                  <a:lnTo>
+                    <a:pt x="3854118" y="977436"/>
+                  </a:lnTo>
+                  <a:lnTo>
+                    <a:pt x="3778547" y="1002845"/>
+                  </a:lnTo>
+                  <a:lnTo>
+                    <a:pt x="3702976" y="1028264"/>
+                  </a:lnTo>
+                  <a:lnTo>
+                    <a:pt x="3627405" y="1053694"/>
+                  </a:lnTo>
+                  <a:lnTo>
+                    <a:pt x="3551834" y="1079135"/>
+                  </a:lnTo>
+                  <a:lnTo>
+                    <a:pt x="3476263" y="1104590"/>
+                  </a:lnTo>
+                  <a:lnTo>
+                    <a:pt x="3400692" y="1130060"/>
+                  </a:lnTo>
+                  <a:lnTo>
+                    <a:pt x="3325121" y="1155546"/>
+                  </a:lnTo>
+                  <a:lnTo>
+                    <a:pt x="3249550" y="1181051"/>
+                  </a:lnTo>
+                  <a:lnTo>
+                    <a:pt x="3173979" y="1206576"/>
+                  </a:lnTo>
+                  <a:lnTo>
+                    <a:pt x="3098408" y="1232125"/>
+                  </a:lnTo>
+                  <a:lnTo>
+                    <a:pt x="3022837" y="1257700"/>
+                  </a:lnTo>
+                  <a:lnTo>
+                    <a:pt x="2947266" y="1283305"/>
+                  </a:lnTo>
+                  <a:lnTo>
+                    <a:pt x="2871695" y="1308944"/>
+                  </a:lnTo>
+                  <a:lnTo>
+                    <a:pt x="2796124" y="1334621"/>
+                  </a:lnTo>
+                  <a:lnTo>
+                    <a:pt x="2720554" y="1360344"/>
+                  </a:lnTo>
+                  <a:lnTo>
+                    <a:pt x="2644983" y="1386118"/>
+                  </a:lnTo>
+                  <a:lnTo>
+                    <a:pt x="2569412" y="1411951"/>
+                  </a:lnTo>
+                  <a:lnTo>
+                    <a:pt x="2493841" y="1437853"/>
+                  </a:lnTo>
+                  <a:lnTo>
+                    <a:pt x="2418270" y="1463834"/>
+                  </a:lnTo>
+                  <a:lnTo>
+                    <a:pt x="2342699" y="1489907"/>
+                  </a:lnTo>
+                  <a:lnTo>
+                    <a:pt x="2267128" y="1516086"/>
+                  </a:lnTo>
+                  <a:lnTo>
+                    <a:pt x="2191557" y="1542386"/>
+                  </a:lnTo>
+                  <a:lnTo>
+                    <a:pt x="2115986" y="1568827"/>
+                  </a:lnTo>
+                  <a:lnTo>
+                    <a:pt x="2040415" y="1595426"/>
+                  </a:lnTo>
+                  <a:lnTo>
+                    <a:pt x="1964844" y="1622202"/>
+                  </a:lnTo>
+                  <a:lnTo>
+                    <a:pt x="1889273" y="1649174"/>
+                  </a:lnTo>
+                  <a:lnTo>
+                    <a:pt x="1813702" y="1676357"/>
+                  </a:lnTo>
+                  <a:lnTo>
+                    <a:pt x="1738131" y="1703761"/>
+                  </a:lnTo>
+                  <a:lnTo>
+                    <a:pt x="1662560" y="1731392"/>
+                  </a:lnTo>
+                  <a:lnTo>
+                    <a:pt x="1586989" y="1759250"/>
+                  </a:lnTo>
+                  <a:lnTo>
+                    <a:pt x="1511418" y="1787328"/>
+                  </a:lnTo>
+                  <a:lnTo>
+                    <a:pt x="1435847" y="1815613"/>
+                  </a:lnTo>
+                  <a:lnTo>
+                    <a:pt x="1360277" y="1844089"/>
+                  </a:lnTo>
+                  <a:lnTo>
+                    <a:pt x="1284706" y="1872738"/>
+                  </a:lnTo>
+                  <a:lnTo>
+                    <a:pt x="1209135" y="1901540"/>
+                  </a:lnTo>
+                  <a:lnTo>
+                    <a:pt x="1133564" y="1930479"/>
+                  </a:lnTo>
+                  <a:lnTo>
+                    <a:pt x="1057993" y="1959535"/>
+                  </a:lnTo>
+                  <a:lnTo>
+                    <a:pt x="982422" y="1988693"/>
+                  </a:lnTo>
+                  <a:lnTo>
+                    <a:pt x="906851" y="2017940"/>
+                  </a:lnTo>
+                  <a:lnTo>
+                    <a:pt x="831280" y="2047263"/>
+                  </a:lnTo>
+                  <a:lnTo>
+                    <a:pt x="755709" y="2076653"/>
+                  </a:lnTo>
+                  <a:lnTo>
+                    <a:pt x="680138" y="2106100"/>
+                  </a:lnTo>
+                  <a:lnTo>
+                    <a:pt x="604567" y="2135596"/>
+                  </a:lnTo>
+                  <a:lnTo>
+                    <a:pt x="528996" y="2165136"/>
+                  </a:lnTo>
+                  <a:lnTo>
+                    <a:pt x="453425" y="2194713"/>
+                  </a:lnTo>
+                  <a:lnTo>
+                    <a:pt x="377854" y="2224323"/>
+                  </a:lnTo>
+                  <a:lnTo>
+                    <a:pt x="302283" y="2253963"/>
+                  </a:lnTo>
+                  <a:lnTo>
+                    <a:pt x="226712" y="2283628"/>
+                  </a:lnTo>
+                  <a:lnTo>
+                    <a:pt x="151141" y="2313315"/>
+                  </a:lnTo>
+                  <a:lnTo>
+                    <a:pt x="75570" y="2343023"/>
+                  </a:lnTo>
+                  <a:lnTo>
+                    <a:pt x="0" y="2372748"/>
+                  </a:lnTo>
+                  <a:close/>
+                </a:path>
+              </a:pathLst>
+            </a:custGeom>
+            <a:solidFill>
+              <a:srgbClr val="E31A1C">
+                <a:alpha val="14901"/>
+              </a:srgbClr>
+            </a:solidFill>
+          </p:spPr>
+          <p:txBody>
+            <a:bodyPr/>
+            <a:lstStyle/>
+            <a:p/>
+          </p:txBody>
+        </p:sp>
+        <p:sp>
+          <p:nvSpPr>
+            <p:cNvPr id="971" name="pl971"/>
+            <p:cNvSpPr/>
+            <p:nvPr/>
+          </p:nvSpPr>
+          <p:spPr>
+            <a:xfrm>
+              <a:off x="1985667" y="2603546"/>
+              <a:ext cx="5970104" cy="2256621"/>
+            </a:xfrm>
+            <a:custGeom>
+              <a:avLst/>
+              <a:pathLst>
+                <a:path w="5970104" h="2256621">
+                  <a:moveTo>
+                    <a:pt x="0" y="2256621"/>
+                  </a:moveTo>
+                  <a:lnTo>
+                    <a:pt x="75570" y="2231139"/>
+                  </a:lnTo>
+                  <a:lnTo>
+                    <a:pt x="151141" y="2205639"/>
+                  </a:lnTo>
+                  <a:lnTo>
+                    <a:pt x="226712" y="2180119"/>
+                  </a:lnTo>
+                  <a:lnTo>
+                    <a:pt x="302283" y="2154576"/>
+                  </a:lnTo>
+                  <a:lnTo>
+                    <a:pt x="377854" y="2129008"/>
+                  </a:lnTo>
+                  <a:lnTo>
+                    <a:pt x="453425" y="2103411"/>
+                  </a:lnTo>
+                  <a:lnTo>
+                    <a:pt x="528996" y="2077781"/>
+                  </a:lnTo>
+                  <a:lnTo>
+                    <a:pt x="604567" y="2052113"/>
+                  </a:lnTo>
+                  <a:lnTo>
+                    <a:pt x="680138" y="2026401"/>
+                  </a:lnTo>
+                  <a:lnTo>
+                    <a:pt x="755709" y="2000641"/>
+                  </a:lnTo>
+                  <a:lnTo>
+                    <a:pt x="831280" y="1974823"/>
+                  </a:lnTo>
+                  <a:lnTo>
+                    <a:pt x="906851" y="1948938"/>
+                  </a:lnTo>
+                  <a:lnTo>
+                    <a:pt x="982422" y="1922978"/>
+                  </a:lnTo>
+                  <a:lnTo>
+                    <a:pt x="1057993" y="1896929"/>
+                  </a:lnTo>
+                  <a:lnTo>
+                    <a:pt x="1133564" y="1870777"/>
+                  </a:lnTo>
+                  <a:lnTo>
+                    <a:pt x="1209135" y="1844507"/>
+                  </a:lnTo>
+                  <a:lnTo>
+                    <a:pt x="1284706" y="1818103"/>
+                  </a:lnTo>
+                  <a:lnTo>
+                    <a:pt x="1360277" y="1791544"/>
+                  </a:lnTo>
+                  <a:lnTo>
+                    <a:pt x="1435847" y="1764812"/>
+                  </a:lnTo>
+                  <a:lnTo>
+                    <a:pt x="1511418" y="1737890"/>
+                  </a:lnTo>
+                  <a:lnTo>
+                    <a:pt x="1586989" y="1710760"/>
+                  </a:lnTo>
+                  <a:lnTo>
+                    <a:pt x="1662560" y="1683410"/>
+                  </a:lnTo>
+                  <a:lnTo>
+                    <a:pt x="1738131" y="1655834"/>
+                  </a:lnTo>
+                  <a:lnTo>
+                    <a:pt x="1813702" y="1628031"/>
+                  </a:lnTo>
+                  <a:lnTo>
+                    <a:pt x="1889273" y="1600005"/>
+                  </a:lnTo>
+                  <a:lnTo>
+                    <a:pt x="1964844" y="1571770"/>
+                  </a:lnTo>
+                  <a:lnTo>
+                    <a:pt x="2040415" y="1543338"/>
+                  </a:lnTo>
+                  <a:lnTo>
+                    <a:pt x="2115986" y="1514730"/>
+                  </a:lnTo>
+                  <a:lnTo>
+                    <a:pt x="2191557" y="1485963"/>
+                  </a:lnTo>
+                  <a:lnTo>
+                    <a:pt x="2267128" y="1457056"/>
+                  </a:lnTo>
+                  <a:lnTo>
+                    <a:pt x="2342699" y="1428027"/>
+                  </a:lnTo>
+                  <a:lnTo>
+                    <a:pt x="2418270" y="1398892"/>
+                  </a:lnTo>
+                  <a:lnTo>
+                    <a:pt x="2493841" y="1369666"/>
+                  </a:lnTo>
+                  <a:lnTo>
+                    <a:pt x="2569412" y="1340360"/>
+                  </a:lnTo>
+                  <a:lnTo>
+                    <a:pt x="2644983" y="1310986"/>
+                  </a:lnTo>
+                  <a:lnTo>
+                    <a:pt x="2720554" y="1281552"/>
+                  </a:lnTo>
+                  <a:lnTo>
+                    <a:pt x="2796124" y="1252067"/>
+                  </a:lnTo>
+                  <a:lnTo>
+                    <a:pt x="2871695" y="1222537"/>
+                  </a:lnTo>
+                  <a:lnTo>
+                    <a:pt x="2947266" y="1192969"/>
+                  </a:lnTo>
+                  <a:lnTo>
+                    <a:pt x="3022837" y="1163366"/>
+                  </a:lnTo>
+                  <a:lnTo>
+                    <a:pt x="3098408" y="1133734"/>
+                  </a:lnTo>
+                  <a:lnTo>
+                    <a:pt x="3173979" y="1104075"/>
+                  </a:lnTo>
+                  <a:lnTo>
+                    <a:pt x="3249550" y="1074392"/>
+                  </a:lnTo>
+                  <a:lnTo>
+                    <a:pt x="3325121" y="1044689"/>
+                  </a:lnTo>
+                  <a:lnTo>
+                    <a:pt x="3400692" y="1014968"/>
+                  </a:lnTo>
+                  <a:lnTo>
+                    <a:pt x="3476263" y="985230"/>
+                  </a:lnTo>
+                  <a:lnTo>
+                    <a:pt x="3551834" y="955477"/>
+                  </a:lnTo>
+                  <a:lnTo>
+                    <a:pt x="3627405" y="925711"/>
+                  </a:lnTo>
+                  <a:lnTo>
+                    <a:pt x="3702976" y="895933"/>
+                  </a:lnTo>
+                  <a:lnTo>
+                    <a:pt x="3778547" y="866144"/>
+                  </a:lnTo>
+                  <a:lnTo>
+                    <a:pt x="3854118" y="836346"/>
+                  </a:lnTo>
+                  <a:lnTo>
+                    <a:pt x="3929689" y="806538"/>
+                  </a:lnTo>
+                  <a:lnTo>
+                    <a:pt x="4005260" y="776723"/>
+                  </a:lnTo>
+                  <a:lnTo>
+                    <a:pt x="4080831" y="746899"/>
+                  </a:lnTo>
+                  <a:lnTo>
+                    <a:pt x="4156401" y="717069"/>
+                  </a:lnTo>
+                  <a:lnTo>
+                    <a:pt x="4231972" y="687233"/>
+                  </a:lnTo>
+                  <a:lnTo>
+                    <a:pt x="4307543" y="657391"/>
+                  </a:lnTo>
+                  <a:lnTo>
+                    <a:pt x="4383114" y="627544"/>
+                  </a:lnTo>
+                  <a:lnTo>
+                    <a:pt x="4458685" y="597692"/>
+                  </a:lnTo>
+                  <a:lnTo>
+                    <a:pt x="4534256" y="567835"/>
+                  </a:lnTo>
+                  <a:lnTo>
+                    <a:pt x="4609827" y="537974"/>
+                  </a:lnTo>
+                  <a:lnTo>
+                    <a:pt x="4685398" y="508109"/>
+                  </a:lnTo>
+                  <a:lnTo>
+                    <a:pt x="4760969" y="478240"/>
+                  </a:lnTo>
+                  <a:lnTo>
+                    <a:pt x="4836540" y="448368"/>
+                  </a:lnTo>
+                  <a:lnTo>
+                    <a:pt x="4912111" y="418493"/>
+                  </a:lnTo>
+                  <a:lnTo>
+                    <a:pt x="4987682" y="388615"/>
+                  </a:lnTo>
+                  <a:lnTo>
+                    <a:pt x="5063253" y="358734"/>
+                  </a:lnTo>
+                  <a:lnTo>
+                    <a:pt x="5138824" y="328851"/>
+                  </a:lnTo>
+                  <a:lnTo>
+                    <a:pt x="5214395" y="298965"/>
+                  </a:lnTo>
+                  <a:lnTo>
+                    <a:pt x="5289966" y="269077"/>
+                  </a:lnTo>
+                  <a:lnTo>
+                    <a:pt x="5365537" y="239186"/>
+                  </a:lnTo>
+                  <a:lnTo>
+                    <a:pt x="5441108" y="209294"/>
+                  </a:lnTo>
+                  <a:lnTo>
+                    <a:pt x="5516678" y="179400"/>
+                  </a:lnTo>
+                  <a:lnTo>
+                    <a:pt x="5592249" y="149504"/>
+                  </a:lnTo>
+                  <a:lnTo>
+                    <a:pt x="5667820" y="119606"/>
+                  </a:lnTo>
+                  <a:lnTo>
+                    <a:pt x="5743391" y="89707"/>
+                  </a:lnTo>
+                  <a:lnTo>
+                    <a:pt x="5818962" y="59806"/>
+                  </a:lnTo>
+                  <a:lnTo>
+                    <a:pt x="5894533" y="29903"/>
+                  </a:lnTo>
+                  <a:lnTo>
+                    <a:pt x="5970104" y="0"/>
+                  </a:lnTo>
+                </a:path>
+              </a:pathLst>
+            </a:custGeom>
+          </p:spPr>
+          <p:txBody>
+            <a:bodyPr/>
+            <a:lstStyle/>
+            <a:p/>
+          </p:txBody>
+        </p:sp>
+        <p:sp>
+          <p:nvSpPr>
+            <p:cNvPr id="972" name="pl972"/>
+            <p:cNvSpPr/>
+            <p:nvPr/>
+          </p:nvSpPr>
+          <p:spPr>
+            <a:xfrm>
+              <a:off x="1985667" y="2871517"/>
+              <a:ext cx="5970104" cy="2104778"/>
+            </a:xfrm>
+            <a:custGeom>
+              <a:avLst/>
+              <a:pathLst>
+                <a:path w="5970104" h="2104778">
+                  <a:moveTo>
+                    <a:pt x="5970104" y="0"/>
+                  </a:moveTo>
+                  <a:lnTo>
+                    <a:pt x="5894533" y="25303"/>
+                  </a:lnTo>
+                  <a:lnTo>
+                    <a:pt x="5818962" y="50609"/>
+                  </a:lnTo>
+                  <a:lnTo>
+                    <a:pt x="5743391" y="75915"/>
+                  </a:lnTo>
+                  <a:lnTo>
+                    <a:pt x="5667820" y="101223"/>
+                  </a:lnTo>
+                  <a:lnTo>
+                    <a:pt x="5592249" y="126533"/>
+                  </a:lnTo>
+                  <a:lnTo>
+                    <a:pt x="5516678" y="151845"/>
+                  </a:lnTo>
+                  <a:lnTo>
+                    <a:pt x="5441108" y="177158"/>
+                  </a:lnTo>
+                  <a:lnTo>
+                    <a:pt x="5365537" y="202473"/>
+                  </a:lnTo>
+                  <a:lnTo>
+                    <a:pt x="5289966" y="227790"/>
+                  </a:lnTo>
+                  <a:lnTo>
+                    <a:pt x="5214395" y="253110"/>
+                  </a:lnTo>
+                  <a:lnTo>
+                    <a:pt x="5138824" y="278432"/>
+                  </a:lnTo>
+                  <a:lnTo>
+                    <a:pt x="5063253" y="303756"/>
+                  </a:lnTo>
+                  <a:lnTo>
+                    <a:pt x="4987682" y="329082"/>
+                  </a:lnTo>
+                  <a:lnTo>
+                    <a:pt x="4912111" y="354412"/>
+                  </a:lnTo>
+                  <a:lnTo>
+                    <a:pt x="4836540" y="379744"/>
+                  </a:lnTo>
+                  <a:lnTo>
+                    <a:pt x="4760969" y="405080"/>
+                  </a:lnTo>
+                  <a:lnTo>
+                    <a:pt x="4685398" y="430419"/>
+                  </a:lnTo>
+                  <a:lnTo>
+                    <a:pt x="4609827" y="455762"/>
+                  </a:lnTo>
+                  <a:lnTo>
+                    <a:pt x="4534256" y="481108"/>
+                  </a:lnTo>
+                  <a:lnTo>
+                    <a:pt x="4458685" y="506459"/>
+                  </a:lnTo>
+                  <a:lnTo>
+                    <a:pt x="4383114" y="531814"/>
+                  </a:lnTo>
+                  <a:lnTo>
+                    <a:pt x="4307543" y="557175"/>
+                  </a:lnTo>
+                  <a:lnTo>
+                    <a:pt x="4231972" y="582540"/>
+                  </a:lnTo>
+                  <a:lnTo>
+                    <a:pt x="4156401" y="607912"/>
+                  </a:lnTo>
+                  <a:lnTo>
+                    <a:pt x="4080831" y="633289"/>
+                  </a:lnTo>
+                  <a:lnTo>
+                    <a:pt x="4005260" y="658674"/>
+                  </a:lnTo>
+                  <a:lnTo>
+                    <a:pt x="3929689" y="684066"/>
+                  </a:lnTo>
+                  <a:lnTo>
+                    <a:pt x="3854118" y="709466"/>
+                  </a:lnTo>
+                  <a:lnTo>
+                    <a:pt x="3778547" y="734875"/>
+                  </a:lnTo>
+                  <a:lnTo>
+                    <a:pt x="3702976" y="760293"/>
+                  </a:lnTo>
+                  <a:lnTo>
+                    <a:pt x="3627405" y="785723"/>
+                  </a:lnTo>
+                  <a:lnTo>
+                    <a:pt x="3551834" y="811165"/>
+                  </a:lnTo>
+                  <a:lnTo>
+                    <a:pt x="3476263" y="836620"/>
+                  </a:lnTo>
+                  <a:lnTo>
+                    <a:pt x="3400692" y="862089"/>
+                  </a:lnTo>
+                  <a:lnTo>
+                    <a:pt x="3325121" y="887575"/>
+                  </a:lnTo>
+                  <a:lnTo>
+                    <a:pt x="3249550" y="913080"/>
+                  </a:lnTo>
+                  <a:lnTo>
+                    <a:pt x="3173979" y="938605"/>
+                  </a:lnTo>
+                  <a:lnTo>
+                    <a:pt x="3098408" y="964154"/>
+                  </a:lnTo>
+                  <a:lnTo>
+                    <a:pt x="3022837" y="989729"/>
+                  </a:lnTo>
+                  <a:lnTo>
+                    <a:pt x="2947266" y="1015334"/>
+                  </a:lnTo>
+                  <a:lnTo>
+                    <a:pt x="2871695" y="1040973"/>
+                  </a:lnTo>
+                  <a:lnTo>
+                    <a:pt x="2796124" y="1066651"/>
+                  </a:lnTo>
+                  <a:lnTo>
+                    <a:pt x="2720554" y="1092373"/>
+                  </a:lnTo>
+                  <a:lnTo>
+                    <a:pt x="2644983" y="1118147"/>
+                  </a:lnTo>
+                  <a:lnTo>
+                    <a:pt x="2569412" y="1143981"/>
+                  </a:lnTo>
+                  <a:lnTo>
+                    <a:pt x="2493841" y="1169882"/>
+                  </a:lnTo>
+                  <a:lnTo>
+                    <a:pt x="2418270" y="1195863"/>
+                  </a:lnTo>
+                  <a:lnTo>
+                    <a:pt x="2342699" y="1221936"/>
+                  </a:lnTo>
+                  <a:lnTo>
+                    <a:pt x="2267128" y="1248115"/>
+                  </a:lnTo>
+                  <a:lnTo>
+                    <a:pt x="2191557" y="1274416"/>
+                  </a:lnTo>
+                  <a:lnTo>
+                    <a:pt x="2115986" y="1300856"/>
+                  </a:lnTo>
+                  <a:lnTo>
+                    <a:pt x="2040415" y="1327455"/>
+                  </a:lnTo>
+                  <a:lnTo>
+                    <a:pt x="1964844" y="1354232"/>
+                  </a:lnTo>
+                  <a:lnTo>
+                    <a:pt x="1889273" y="1381203"/>
+                  </a:lnTo>
+                  <a:lnTo>
+                    <a:pt x="1813702" y="1408386"/>
+                  </a:lnTo>
+                  <a:lnTo>
+                    <a:pt x="1738131" y="1435790"/>
+                  </a:lnTo>
+                  <a:lnTo>
+                    <a:pt x="1662560" y="1463422"/>
+                  </a:lnTo>
+                  <a:lnTo>
+                    <a:pt x="1586989" y="1491280"/>
+                  </a:lnTo>
+                  <a:lnTo>
+                    <a:pt x="1511418" y="1519357"/>
+                  </a:lnTo>
+                  <a:lnTo>
+                    <a:pt x="1435847" y="1547642"/>
+                  </a:lnTo>
+                  <a:lnTo>
+                    <a:pt x="1360277" y="1576118"/>
+                  </a:lnTo>
+                  <a:lnTo>
+                    <a:pt x="1284706" y="1604767"/>
+                  </a:lnTo>
+                  <a:lnTo>
+                    <a:pt x="1209135" y="1633570"/>
+                  </a:lnTo>
+                  <a:lnTo>
+                    <a:pt x="1133564" y="1662508"/>
+                  </a:lnTo>
+                  <a:lnTo>
+                    <a:pt x="1057993" y="1691564"/>
+                  </a:lnTo>
+                  <a:lnTo>
+                    <a:pt x="982422" y="1720722"/>
+                  </a:lnTo>
+                  <a:lnTo>
+                    <a:pt x="906851" y="1749969"/>
+                  </a:lnTo>
+                  <a:lnTo>
+                    <a:pt x="831280" y="1779293"/>
+                  </a:lnTo>
+                  <a:lnTo>
+                    <a:pt x="755709" y="1808682"/>
+                  </a:lnTo>
+                  <a:lnTo>
+                    <a:pt x="680138" y="1838129"/>
+                  </a:lnTo>
+                  <a:lnTo>
+                    <a:pt x="604567" y="1867625"/>
+                  </a:lnTo>
+                  <a:lnTo>
+                    <a:pt x="528996" y="1897165"/>
+                  </a:lnTo>
+                  <a:lnTo>
+                    <a:pt x="453425" y="1926742"/>
+                  </a:lnTo>
+                  <a:lnTo>
+                    <a:pt x="377854" y="1956353"/>
+                  </a:lnTo>
+                  <a:lnTo>
+                    <a:pt x="302283" y="1985992"/>
+                  </a:lnTo>
+                  <a:lnTo>
+                    <a:pt x="226712" y="2015657"/>
+                  </a:lnTo>
+                  <a:lnTo>
+                    <a:pt x="151141" y="2045344"/>
+                  </a:lnTo>
+                  <a:lnTo>
+                    <a:pt x="75570" y="2075052"/>
+                  </a:lnTo>
+                  <a:lnTo>
+                    <a:pt x="0" y="2104778"/>
+                  </a:lnTo>
+                </a:path>
+              </a:pathLst>
+            </a:custGeom>
+          </p:spPr>
+          <p:txBody>
+            <a:bodyPr/>
+            <a:lstStyle/>
+            <a:p/>
+          </p:txBody>
+        </p:sp>
+        <p:sp>
+          <p:nvSpPr>
+            <p:cNvPr id="973" name="pl973"/>
+            <p:cNvSpPr/>
+            <p:nvPr/>
+          </p:nvSpPr>
+          <p:spPr>
+            <a:xfrm>
+              <a:off x="1985667" y="2737531"/>
+              <a:ext cx="5970104" cy="2180699"/>
+            </a:xfrm>
+            <a:custGeom>
+              <a:avLst/>
+              <a:pathLst>
+                <a:path w="5970104" h="2180699">
+                  <a:moveTo>
+                    <a:pt x="0" y="2180699"/>
+                  </a:moveTo>
+                  <a:lnTo>
+                    <a:pt x="75570" y="2153096"/>
+                  </a:lnTo>
+                  <a:lnTo>
+                    <a:pt x="151141" y="2125492"/>
+                  </a:lnTo>
+                  <a:lnTo>
+                    <a:pt x="226712" y="2097888"/>
+                  </a:lnTo>
+                  <a:lnTo>
+                    <a:pt x="302283" y="2070284"/>
+                  </a:lnTo>
+                  <a:lnTo>
+                    <a:pt x="377854" y="2042680"/>
+                  </a:lnTo>
+                  <a:lnTo>
+                    <a:pt x="453425" y="2015077"/>
+                  </a:lnTo>
+                  <a:lnTo>
+                    <a:pt x="528996" y="1987473"/>
+                  </a:lnTo>
+                  <a:lnTo>
+                    <a:pt x="604567" y="1959869"/>
+                  </a:lnTo>
+                  <a:lnTo>
+                    <a:pt x="680138" y="1932265"/>
+                  </a:lnTo>
+                  <a:lnTo>
+                    <a:pt x="755709" y="1904661"/>
+                  </a:lnTo>
+                  <a:lnTo>
+                    <a:pt x="831280" y="1877058"/>
+                  </a:lnTo>
+                  <a:lnTo>
+                    <a:pt x="906851" y="1849454"/>
+                  </a:lnTo>
+                  <a:lnTo>
+                    <a:pt x="982422" y="1821850"/>
+                  </a:lnTo>
+                  <a:lnTo>
+                    <a:pt x="1057993" y="1794246"/>
+                  </a:lnTo>
+                  <a:lnTo>
+                    <a:pt x="1133564" y="1766642"/>
+                  </a:lnTo>
+                  <a:lnTo>
+                    <a:pt x="1209135" y="1739039"/>
+                  </a:lnTo>
+                  <a:lnTo>
+                    <a:pt x="1284706" y="1711435"/>
+                  </a:lnTo>
+                  <a:lnTo>
+                    <a:pt x="1360277" y="1683831"/>
+                  </a:lnTo>
+                  <a:lnTo>
+                    <a:pt x="1435847" y="1656227"/>
+                  </a:lnTo>
+                  <a:lnTo>
+                    <a:pt x="1511418" y="1628623"/>
+                  </a:lnTo>
+                  <a:lnTo>
+                    <a:pt x="1586989" y="1601020"/>
+                  </a:lnTo>
+                  <a:lnTo>
+                    <a:pt x="1662560" y="1573416"/>
+                  </a:lnTo>
+                  <a:lnTo>
+                    <a:pt x="1738131" y="1545812"/>
+                  </a:lnTo>
+                  <a:lnTo>
+                    <a:pt x="1813702" y="1518208"/>
+                  </a:lnTo>
+                  <a:lnTo>
+                    <a:pt x="1889273" y="1490604"/>
+                  </a:lnTo>
+                  <a:lnTo>
+                    <a:pt x="1964844" y="1463001"/>
+                  </a:lnTo>
+                  <a:lnTo>
+                    <a:pt x="2040415" y="1435397"/>
+                  </a:lnTo>
+                  <a:lnTo>
+                    <a:pt x="2115986" y="1407793"/>
+                  </a:lnTo>
+                  <a:lnTo>
+                    <a:pt x="2191557" y="1380189"/>
+                  </a:lnTo>
+                  <a:lnTo>
+                    <a:pt x="2267128" y="1352585"/>
+                  </a:lnTo>
+                  <a:lnTo>
+                    <a:pt x="2342699" y="1324982"/>
+                  </a:lnTo>
+                  <a:lnTo>
+                    <a:pt x="2418270" y="1297378"/>
+                  </a:lnTo>
+                  <a:lnTo>
+                    <a:pt x="2493841" y="1269774"/>
+                  </a:lnTo>
+                  <a:lnTo>
+                    <a:pt x="2569412" y="1242170"/>
+                  </a:lnTo>
+                  <a:lnTo>
+                    <a:pt x="2644983" y="1214566"/>
+                  </a:lnTo>
+                  <a:lnTo>
+                    <a:pt x="2720554" y="1186963"/>
+                  </a:lnTo>
+                  <a:lnTo>
+                    <a:pt x="2796124" y="1159359"/>
+                  </a:lnTo>
+                  <a:lnTo>
+                    <a:pt x="2871695" y="1131755"/>
+                  </a:lnTo>
+                  <a:lnTo>
+                    <a:pt x="2947266" y="1104151"/>
+                  </a:lnTo>
+                  <a:lnTo>
+                    <a:pt x="3022837" y="1076548"/>
+                  </a:lnTo>
+                  <a:lnTo>
+                    <a:pt x="3098408" y="1048944"/>
+                  </a:lnTo>
+                  <a:lnTo>
+                    <a:pt x="3173979" y="1021340"/>
+                  </a:lnTo>
+                  <a:lnTo>
+                    <a:pt x="3249550" y="993736"/>
+                  </a:lnTo>
+                  <a:lnTo>
+                    <a:pt x="3325121" y="966132"/>
+                  </a:lnTo>
+                  <a:lnTo>
+                    <a:pt x="3400692" y="938529"/>
+                  </a:lnTo>
+                  <a:lnTo>
+                    <a:pt x="3476263" y="910925"/>
+                  </a:lnTo>
+                  <a:lnTo>
+                    <a:pt x="3551834" y="883321"/>
+                  </a:lnTo>
+                  <a:lnTo>
+                    <a:pt x="3627405" y="855717"/>
+                  </a:lnTo>
+                  <a:lnTo>
+                    <a:pt x="3702976" y="828113"/>
+                  </a:lnTo>
+                  <a:lnTo>
+                    <a:pt x="3778547" y="800510"/>
+                  </a:lnTo>
+                  <a:lnTo>
+                    <a:pt x="3854118" y="772906"/>
+                  </a:lnTo>
+                  <a:lnTo>
+                    <a:pt x="3929689" y="745302"/>
+                  </a:lnTo>
+                  <a:lnTo>
+                    <a:pt x="4005260" y="717698"/>
+                  </a:lnTo>
+                  <a:lnTo>
+                    <a:pt x="4080831" y="690094"/>
+                  </a:lnTo>
+                  <a:lnTo>
+                    <a:pt x="4156401" y="662491"/>
+                  </a:lnTo>
+                  <a:lnTo>
+                    <a:pt x="4231972" y="634887"/>
+                  </a:lnTo>
+                  <a:lnTo>
+                    <a:pt x="4307543" y="607283"/>
+                  </a:lnTo>
+                  <a:lnTo>
+                    <a:pt x="4383114" y="579679"/>
+                  </a:lnTo>
+                  <a:lnTo>
+                    <a:pt x="4458685" y="552075"/>
+                  </a:lnTo>
+                  <a:lnTo>
+                    <a:pt x="4534256" y="524472"/>
+                  </a:lnTo>
+                  <a:lnTo>
+                    <a:pt x="4609827" y="496868"/>
+                  </a:lnTo>
+                  <a:lnTo>
+                    <a:pt x="4685398" y="469264"/>
+                  </a:lnTo>
+                  <a:lnTo>
+                    <a:pt x="4760969" y="441660"/>
+                  </a:lnTo>
+                  <a:lnTo>
+                    <a:pt x="4836540" y="414056"/>
+                  </a:lnTo>
+                  <a:lnTo>
+                    <a:pt x="4912111" y="386453"/>
+                  </a:lnTo>
+                  <a:lnTo>
+                    <a:pt x="4987682" y="358849"/>
+                  </a:lnTo>
+                  <a:lnTo>
+                    <a:pt x="5063253" y="331245"/>
+                  </a:lnTo>
+                  <a:lnTo>
+                    <a:pt x="5138824" y="303641"/>
+                  </a:lnTo>
+                  <a:lnTo>
+                    <a:pt x="5214395" y="276037"/>
+                  </a:lnTo>
+                  <a:lnTo>
+                    <a:pt x="5289966" y="248434"/>
+                  </a:lnTo>
+                  <a:lnTo>
+                    <a:pt x="5365537" y="220830"/>
+                  </a:lnTo>
+                  <a:lnTo>
+                    <a:pt x="5441108" y="193226"/>
+                  </a:lnTo>
+                  <a:lnTo>
+                    <a:pt x="5516678" y="165622"/>
+                  </a:lnTo>
+                  <a:lnTo>
+                    <a:pt x="5592249" y="138018"/>
+                  </a:lnTo>
+                  <a:lnTo>
+                    <a:pt x="5667820" y="110415"/>
+                  </a:lnTo>
+                  <a:lnTo>
+                    <a:pt x="5743391" y="82811"/>
+                  </a:lnTo>
+                  <a:lnTo>
+                    <a:pt x="5818962" y="55207"/>
+                  </a:lnTo>
+                  <a:lnTo>
+                    <a:pt x="5894533" y="27603"/>
+                  </a:lnTo>
+                  <a:lnTo>
+                    <a:pt x="5970104" y="0"/>
+                  </a:lnTo>
+                </a:path>
+              </a:pathLst>
+            </a:custGeom>
+            <a:ln w="27101" cap="flat">
+              <a:solidFill>
+                <a:srgbClr val="E31A1C">
+                  <a:alpha val="100000"/>
+                </a:srgbClr>
+              </a:solidFill>
+              <a:prstDash val="solid"/>
+              <a:round/>
+            </a:ln>
+          </p:spPr>
+          <p:txBody>
+            <a:bodyPr/>
+            <a:lstStyle/>
+            <a:p/>
+          </p:txBody>
+        </p:sp>
+        <p:sp>
+          <p:nvSpPr>
+            <p:cNvPr id="974" name="tx974"/>
             <p:cNvSpPr/>
             <p:nvPr/>
           </p:nvSpPr>
@@ -36130,7 +38175,7 @@
         </p:sp>
         <p:sp>
           <p:nvSpPr>
-            <p:cNvPr id="967" name="tx967"/>
+            <p:cNvPr id="975" name="tx975"/>
             <p:cNvSpPr/>
             <p:nvPr/>
           </p:nvSpPr>
@@ -36176,7 +38221,7 @@
         </p:sp>
         <p:sp>
           <p:nvSpPr>
-            <p:cNvPr id="968" name="tx968"/>
+            <p:cNvPr id="976" name="tx976"/>
             <p:cNvSpPr/>
             <p:nvPr/>
           </p:nvSpPr>
@@ -36222,7 +38267,7 @@
         </p:sp>
         <p:sp>
           <p:nvSpPr>
-            <p:cNvPr id="969" name="tx969"/>
+            <p:cNvPr id="977" name="tx977"/>
             <p:cNvSpPr/>
             <p:nvPr/>
           </p:nvSpPr>
@@ -36268,7 +38313,7 @@
         </p:sp>
         <p:sp>
           <p:nvSpPr>
-            <p:cNvPr id="970" name="tx970"/>
+            <p:cNvPr id="978" name="tx978"/>
             <p:cNvSpPr/>
             <p:nvPr/>
           </p:nvSpPr>
@@ -36314,7 +38359,7 @@
         </p:sp>
         <p:sp>
           <p:nvSpPr>
-            <p:cNvPr id="971" name="tx971"/>
+            <p:cNvPr id="979" name="tx979"/>
             <p:cNvSpPr/>
             <p:nvPr/>
           </p:nvSpPr>
@@ -36360,7 +38405,7 @@
         </p:sp>
         <p:sp>
           <p:nvSpPr>
-            <p:cNvPr id="972" name="tx972"/>
+            <p:cNvPr id="980" name="tx980"/>
             <p:cNvSpPr/>
             <p:nvPr/>
           </p:nvSpPr>
@@ -36406,7 +38451,7 @@
         </p:sp>
         <p:sp>
           <p:nvSpPr>
-            <p:cNvPr id="973" name="tx973"/>
+            <p:cNvPr id="981" name="tx981"/>
             <p:cNvSpPr/>
             <p:nvPr/>
           </p:nvSpPr>
@@ -36452,7 +38497,7 @@
         </p:sp>
         <p:sp>
           <p:nvSpPr>
-            <p:cNvPr id="974" name="tx974"/>
+            <p:cNvPr id="982" name="tx982"/>
             <p:cNvSpPr/>
             <p:nvPr/>
           </p:nvSpPr>
@@ -36498,7 +38543,7 @@
         </p:sp>
         <p:sp>
           <p:nvSpPr>
-            <p:cNvPr id="975" name="tx975"/>
+            <p:cNvPr id="983" name="tx983"/>
             <p:cNvSpPr/>
             <p:nvPr/>
           </p:nvSpPr>
@@ -36544,7 +38589,7 @@
         </p:sp>
         <p:sp>
           <p:nvSpPr>
-            <p:cNvPr id="976" name="tx976"/>
+            <p:cNvPr id="984" name="tx984"/>
             <p:cNvSpPr/>
             <p:nvPr/>
           </p:nvSpPr>
@@ -36590,7 +38635,7 @@
         </p:sp>
         <p:sp>
           <p:nvSpPr>
-            <p:cNvPr id="977" name="tx977"/>
+            <p:cNvPr id="985" name="tx985"/>
             <p:cNvSpPr/>
             <p:nvPr/>
           </p:nvSpPr>
@@ -36636,7 +38681,7 @@
         </p:sp>
         <p:sp>
           <p:nvSpPr>
-            <p:cNvPr id="978" name="tx978"/>
+            <p:cNvPr id="986" name="tx986"/>
             <p:cNvSpPr/>
             <p:nvPr/>
           </p:nvSpPr>

</xml_diff>